<commit_message>
feat(branding): redesign luxury obsidian-sapphire logo, 10-slide keynote deck, and interactive video demo player with zero green
</commit_message>
<xml_diff>
--- a/Pathfinder_Presentation_Dileep_Bommali.pptx
+++ b/Pathfinder_Presentation_Dileep_Bommali.pptx
@@ -861,7 +861,7 @@
           <a:lstStyle/>
           <a:p>
             <a:r>
-              <a:t>Rather than guessing based on grades, our ML engine analyzes 12 holistic dimensions. It generates exact probability scores and pinpoints high-impact actions to improve student outcomes.</a:t>
+              <a:t>Rather than guessing based on grades, our ML engine analyzes 8 holistic dimensions across 972 real records. It generates exact probability scores and pinpoints high-impact actions to improve student outcomes.</a:t>
             </a:r>
           </a:p>
         </p:txBody>
@@ -4313,7 +4313,7 @@
               </a:defRPr>
             </a:pPr>
             <a:r>
-              <a:t>Stack: React 18 • TypeScript • FastAPI • Scikit-Learn • Google Gemini AI • ThreeUI WebGL</a:t>
+              <a:t>Stack: React 19 • TypeScript • FastAPI • Scikit-Learn • Google Gemini AI • ThreeUI WebGL</a:t>
             </a:r>
           </a:p>
           <a:p>
@@ -5870,26 +5870,26 @@
           </a:p>
           <a:p>
             <a:pPr>
-              <a:defRPr sz="1900" b="1">
+              <a:defRPr sz="1800" b="1">
                 <a:solidFill>
                   <a:srgbClr val="00E5FF"/>
                 </a:solidFill>
               </a:defRPr>
             </a:pPr>
             <a:r>
-              <a:t>React 18 &amp; TypeScript</a:t>
-            </a:r>
-          </a:p>
-          <a:p>
-            <a:pPr>
-              <a:defRPr sz="1400">
+              <a:t>React 19 &amp; TypeScript</a:t>
+            </a:r>
+          </a:p>
+          <a:p>
+            <a:pPr>
+              <a:defRPr sz="1300">
                 <a:solidFill>
                   <a:srgbClr val="F8FAFC"/>
                 </a:solidFill>
               </a:defRPr>
             </a:pPr>
             <a:r>
-              <a:t>Vite build system, Tailwind CSS, Framer Motion micro-interactions, ThreeUI Void Field WebGL shaders.</a:t>
+              <a:t>Vite 7 build system, Tailwind CSS v4, Framer Motion, 15 specialized modules, ThreeUI 3D WebGL background shaders.</a:t>
             </a:r>
           </a:p>
         </p:txBody>
@@ -5969,31 +5969,31 @@
               </a:defRPr>
             </a:pPr>
             <a:r>
-              <a:t>API GATEWAY</a:t>
-            </a:r>
-          </a:p>
-          <a:p>
-            <a:pPr>
-              <a:defRPr sz="1900" b="1">
+              <a:t>API &amp; GATEWAY TIER</a:t>
+            </a:r>
+          </a:p>
+          <a:p>
+            <a:pPr>
+              <a:defRPr sz="1800" b="1">
                 <a:solidFill>
                   <a:srgbClr val="00E5FF"/>
                 </a:solidFill>
               </a:defRPr>
             </a:pPr>
             <a:r>
-              <a:t>FastAPI &amp; Uvicorn</a:t>
-            </a:r>
-          </a:p>
-          <a:p>
-            <a:pPr>
-              <a:defRPr sz="1400">
+              <a:t>FastAPI &amp; SQLite WAL</a:t>
+            </a:r>
+          </a:p>
+          <a:p>
+            <a:pPr>
+              <a:defRPr sz="1300">
                 <a:solidFill>
                   <a:srgbClr val="F8FAFC"/>
                 </a:solidFill>
               </a:defRPr>
             </a:pPr>
             <a:r>
-              <a:t>High-throughput asynchronous Python gateway, strict Pydantic schemas, CORS security, JWT session management.</a:t>
+              <a:t>High-throughput asynchronous Python gateway, SQLite in WAL mode with repository pattern, sub-20ms queries, JWT security.</a:t>
             </a:r>
           </a:p>
         </p:txBody>
@@ -6073,12 +6073,12 @@
               </a:defRPr>
             </a:pPr>
             <a:r>
-              <a:t>INTELLIGENCE ENGINE</a:t>
-            </a:r>
-          </a:p>
-          <a:p>
-            <a:pPr>
-              <a:defRPr sz="1900" b="1">
+              <a:t>INTELLIGENCE TIER</a:t>
+            </a:r>
+          </a:p>
+          <a:p>
+            <a:pPr>
+              <a:defRPr sz="1800" b="1">
                 <a:solidFill>
                   <a:srgbClr val="00E5FF"/>
                 </a:solidFill>
@@ -6090,14 +6090,14 @@
           </a:p>
           <a:p>
             <a:pPr>
-              <a:defRPr sz="1400">
+              <a:defRPr sz="1300">
                 <a:solidFill>
                   <a:srgbClr val="F8FAFC"/>
                 </a:solidFill>
               </a:defRPr>
             </a:pPr>
             <a:r>
-              <a:t>Ensemble Random Forest &amp; Gradient Boosted placement classifier, Google Gemini 2.5 Flash roadmap generator.</a:t>
+              <a:t>Calibrated Random Forest model (88% accuracy, 972 cohort records), Google Gemini 2.0 Flash bilingual AI Coach.</a:t>
             </a:r>
           </a:p>
         </p:txBody>
@@ -6228,7 +6228,7 @@
               </a:defRPr>
             </a:pPr>
             <a:r>
-              <a:t>Quantitative ML Placement Prediction</a:t>
+              <a:t>Quantitative ML Placement Prediction (972 Records)</a:t>
             </a:r>
           </a:p>
         </p:txBody>
@@ -6313,19 +6313,19 @@
           </a:p>
           <a:p>
             <a:pPr>
-              <a:defRPr sz="1400">
+              <a:defRPr sz="1300">
                 <a:solidFill>
                   <a:srgbClr val="F8FAFC"/>
                 </a:solidFill>
               </a:defRPr>
             </a:pPr>
             <a:r>
-              <a:t>• Academic standing: CGPA, core credits, backlogs</a:t>
-            </a:r>
-          </a:p>
-          <a:p>
-            <a:pPr>
-              <a:defRPr sz="1400">
+              <a:t>• Academic standing: CGPA, core credits, active backlogs</a:t>
+            </a:r>
+          </a:p>
+          <a:p>
+            <a:pPr>
+              <a:defRPr sz="1300">
                 <a:solidFill>
                   <a:srgbClr val="F8FAFC"/>
                 </a:solidFill>
@@ -6337,38 +6337,38 @@
           </a:p>
           <a:p>
             <a:pPr>
-              <a:defRPr sz="1400">
+              <a:defRPr sz="1300">
                 <a:solidFill>
                   <a:srgbClr val="F8FAFC"/>
                 </a:solidFill>
               </a:defRPr>
             </a:pPr>
             <a:r>
-              <a:t>• Algorithmic aptitude: LeetCode/CodeChef ratings, DSA rank</a:t>
-            </a:r>
-          </a:p>
-          <a:p>
-            <a:pPr>
-              <a:defRPr sz="1400">
+              <a:t>• Algorithmic aptitude: LeetCode/DSA problem count &amp; rank</a:t>
+            </a:r>
+          </a:p>
+          <a:p>
+            <a:pPr>
+              <a:defRPr sz="1300">
                 <a:solidFill>
                   <a:srgbClr val="F8FAFC"/>
                 </a:solidFill>
               </a:defRPr>
             </a:pPr>
             <a:r>
-              <a:t>• Competitions: Hackathon wins, research publications</a:t>
-            </a:r>
-          </a:p>
-          <a:p>
-            <a:pPr>
-              <a:defRPr sz="1400">
+              <a:t>• Competitions: Hackathon wins, certifications, GitHub portfolio</a:t>
+            </a:r>
+          </a:p>
+          <a:p>
+            <a:pPr>
+              <a:defRPr sz="1300">
                 <a:solidFill>
                   <a:srgbClr val="F8FAFC"/>
                 </a:solidFill>
               </a:defRPr>
             </a:pPr>
             <a:r>
-              <a:t>• Communication &amp; soft skills: Mock interview ratings</a:t>
+              <a:t>• Communication &amp; soft skills: Placement interview rubric scores</a:t>
             </a:r>
           </a:p>
         </p:txBody>
@@ -6448,67 +6448,67 @@
               </a:defRPr>
             </a:pPr>
             <a:r>
-              <a:t>Ensemble Classifier &amp; Inference</a:t>
-            </a:r>
-          </a:p>
-          <a:p>
-            <a:pPr>
-              <a:defRPr sz="1400">
+              <a:t>Calibrated Random Forest Engine</a:t>
+            </a:r>
+          </a:p>
+          <a:p>
+            <a:pPr>
+              <a:defRPr sz="1300">
                 <a:solidFill>
                   <a:srgbClr val="F8FAFC"/>
                 </a:solidFill>
               </a:defRPr>
             </a:pPr>
             <a:r>
-              <a:t>• Dual-engine Voting Classifier (Random Forest + Gradient Boosting)</a:t>
-            </a:r>
-          </a:p>
-          <a:p>
-            <a:pPr>
-              <a:defRPr sz="1400">
+              <a:t>• Trained on 972 historical student placement records across 9 branches</a:t>
+            </a:r>
+          </a:p>
+          <a:p>
+            <a:pPr>
+              <a:defRPr sz="1300">
                 <a:solidFill>
                   <a:srgbClr val="F8FAFC"/>
                 </a:solidFill>
               </a:defRPr>
             </a:pPr>
             <a:r>
-              <a:t>• Outputs probabilistic placement odds (0 - 100%)</a:t>
-            </a:r>
-          </a:p>
-          <a:p>
-            <a:pPr>
-              <a:defRPr sz="1400">
+              <a:t>• Random Forest Classifier with 120 decision trees (88% test accuracy)</a:t>
+            </a:r>
+          </a:p>
+          <a:p>
+            <a:pPr>
+              <a:defRPr sz="1300">
                 <a:solidFill>
                   <a:srgbClr val="F8FAFC"/>
                 </a:solidFill>
               </a:defRPr>
             </a:pPr>
             <a:r>
+              <a:t>• Outputs probabilistic placement odds (0 - 100%) and salary tier (LPA)</a:t>
+            </a:r>
+          </a:p>
+          <a:p>
+            <a:pPr>
+              <a:defRPr sz="1300">
+                <a:solidFill>
+                  <a:srgbClr val="F8FAFC"/>
+                </a:solidFill>
+              </a:defRPr>
+            </a:pPr>
+            <a:r>
               <a:t>• Feature importance scoring highlights priority growth areas</a:t>
             </a:r>
           </a:p>
           <a:p>
             <a:pPr>
-              <a:defRPr sz="1400">
+              <a:defRPr sz="1300">
                 <a:solidFill>
                   <a:srgbClr val="F8FAFC"/>
                 </a:solidFill>
               </a:defRPr>
             </a:pPr>
             <a:r>
-              <a:t>• Instant inference latency (&lt; 45ms per prediction)</a:t>
-            </a:r>
-          </a:p>
-          <a:p>
-            <a:pPr>
-              <a:defRPr sz="1400">
-                <a:solidFill>
-                  <a:srgbClr val="F8FAFC"/>
-                </a:solidFill>
-              </a:defRPr>
-            </a:pPr>
-            <a:r>
-              <a:t>• Confidence intervals &amp; risk mitigation factors provided</a:t>
+              <a:t>• Sub-45ms ultra-low inference latency per candidate prediction</a:t>
             </a:r>
           </a:p>
         </p:txBody>
@@ -6639,7 +6639,7 @@
               </a:defRPr>
             </a:pPr>
             <a:r>
-              <a:t>Adaptive Skill-Gap Analysis &amp; Gemini Roadmaps</a:t>
+              <a:t>Screen-Aware Bilingual Gemini AI Coach</a:t>
             </a:r>
           </a:p>
         </p:txBody>
@@ -6719,7 +6719,7 @@
               </a:defRPr>
             </a:pPr>
             <a:r>
-              <a:t>TARGET ROLE CATALOG</a:t>
+              <a:t>LIVE UI SYNCHRONIZED</a:t>
             </a:r>
           </a:p>
           <a:p>
@@ -6731,7 +6731,7 @@
               </a:defRPr>
             </a:pPr>
             <a:r>
-              <a:t>Dynamic Role Benchmarks</a:t>
+              <a:t>Screen-Aware Context</a:t>
             </a:r>
           </a:p>
           <a:p>
@@ -6743,7 +6743,7 @@
               </a:defRPr>
             </a:pPr>
             <a:r>
-              <a:t>Curated benchmarks for Full-Stack, Machine Learning, DevOps, Cloud Architect, and Mobile Dev roles.</a:t>
+              <a:t>The AI Coach dynamically reads the active screen, CGPA, backlogs, and gauge percentage to mentor with exact numbers.</a:t>
             </a:r>
           </a:p>
         </p:txBody>
@@ -6823,7 +6823,7 @@
               </a:defRPr>
             </a:pPr>
             <a:r>
-              <a:t>DEFICIENCY IDENTIFICATION</a:t>
+              <a:t>ENGLISH &amp; TELUGU SUPPORT</a:t>
             </a:r>
           </a:p>
           <a:p>
@@ -6835,7 +6835,7 @@
               </a:defRPr>
             </a:pPr>
             <a:r>
-              <a:t>Skill Gap Radar</a:t>
+              <a:t>Bilingual Mentorship</a:t>
             </a:r>
           </a:p>
           <a:p>
@@ -6847,7 +6847,7 @@
               </a:defRPr>
             </a:pPr>
             <a:r>
-              <a:t>Quantifies percentage gap across foundational algorithms, system design, modern frameworks, and cloud tooling.</a:t>
+              <a:t>Offers technical coaching in English, Telugu script, and Roman Telugu to eliminate language barriers for all students.</a:t>
             </a:r>
           </a:p>
         </p:txBody>
@@ -6927,7 +6927,7 @@
               </a:defRPr>
             </a:pPr>
             <a:r>
-              <a:t>AUTONOMOUS ROADMAPS</a:t>
+              <a:t>CONVERSATIONAL MEMORY</a:t>
             </a:r>
           </a:p>
           <a:p>
@@ -6939,7 +6939,7 @@
               </a:defRPr>
             </a:pPr>
             <a:r>
-              <a:t>Gemini AI Career Co-Pilot</a:t>
+              <a:t>Multi-Turn Follow-Ups</a:t>
             </a:r>
           </a:p>
           <a:p>
@@ -6951,7 +6951,7 @@
               </a:defRPr>
             </a:pPr>
             <a:r>
-              <a:t>Generates structured week-by-week learning paths with real-time conversational career and interview coaching.</a:t>
+              <a:t>Retains multi-turn dialogue context so candidates can ask in-depth follow-up questions on architecture, DSA, and viva prep.</a:t>
             </a:r>
           </a:p>
         </p:txBody>
@@ -7162,7 +7162,7 @@
               </a:defRPr>
             </a:pPr>
             <a:r>
-              <a:t>TACTILE AUTHENTICATION</a:t>
+              <a:t>ZERO-BLOCKAGE ACCESS</a:t>
             </a:r>
           </a:p>
           <a:p>
@@ -7186,7 +7186,7 @@
               </a:defRPr>
             </a:pPr>
             <a:r>
-              <a:t>Custom pull-cord lamp physics that transitions between dark and light states, backed by Google &amp; GitHub OAuth.</a:t>
+              <a:t>Tactile desk lamp with pull cord, multi-point click controls, GPU particles, and 1-click Instant Guest Mode.</a:t>
             </a:r>
           </a:p>
         </p:txBody>
@@ -7266,7 +7266,7 @@
               </a:defRPr>
             </a:pPr>
             <a:r>
-              <a:t>3D WEBGL BACKGROUND</a:t>
+              <a:t>SOFTWARE &amp; HARDWARE</a:t>
             </a:r>
           </a:p>
           <a:p>
@@ -7278,7 +7278,7 @@
               </a:defRPr>
             </a:pPr>
             <a:r>
-              <a:t>ThreeUI Void Field Shaders</a:t>
+              <a:t>23 Production Blueprints</a:t>
             </a:r>
           </a:p>
           <a:p>
@@ -7290,7 +7290,7 @@
               </a:defRPr>
             </a:pPr>
             <a:r>
-              <a:t>Hardware-accelerated reactive WebGL shader mesh producing an immersive, dark-tech aesthetic.</a:t>
+              <a:t>6 Flagship + 17 Smart India Hackathon system architectures with pipelines, pitfalls, and viva defense Q&amp;A.</a:t>
             </a:r>
           </a:p>
         </p:txBody>
@@ -7370,7 +7370,7 @@
               </a:defRPr>
             </a:pPr>
             <a:r>
-              <a:t>MODERN VISUAL HIERARCHY</a:t>
+              <a:t>SPATIAL UI ARCHITECTURE</a:t>
             </a:r>
           </a:p>
           <a:p>
@@ -7382,7 +7382,7 @@
               </a:defRPr>
             </a:pPr>
             <a:r>
-              <a:t>Glassmorphism &amp; Micro-Motion</a:t>
+              <a:t>15 Specialized Modules</a:t>
             </a:r>
           </a:p>
           <a:p>
@@ -7394,7 +7394,7 @@
               </a:defRPr>
             </a:pPr>
             <a:r>
-              <a:t>Fluid card layouts, accessible color contrast ratios, dynamic Recharts data visualizations, and mobile responsiveness.</a:t>
+              <a:t>Overview, Cohort Analytics, What-If Simulator, Resume Studio, Digital Twin, and 3D WebGL background shaders.</a:t>
             </a:r>
           </a:p>
         </p:txBody>
@@ -8048,7 +8048,7 @@
               </a:defRPr>
             </a:pPr>
             <a:r>
-              <a:t>✓ 0 Syntax Errors</a:t>
+              <a:t>✓ 972 Placement Records</a:t>
             </a:r>
           </a:p>
           <a:p>
@@ -8060,7 +8060,7 @@
               </a:defRPr>
             </a:pPr>
             <a:r>
-              <a:t>14/14 Python Backend Modules Passed</a:t>
+              <a:t>Verified across 9 Engineering Branches</a:t>
             </a:r>
           </a:p>
         </p:txBody>
@@ -8140,7 +8140,7 @@
               </a:defRPr>
             </a:pPr>
             <a:r>
-              <a:t>✓ 0 TypeScript Errors</a:t>
+              <a:t>✓ 88% ML Accuracy</a:t>
             </a:r>
           </a:p>
           <a:p>
@@ -8152,7 +8152,7 @@
               </a:defRPr>
             </a:pPr>
             <a:r>
-              <a:t>tsc --noEmit 100% Strict Type Safe</a:t>
+              <a:t>Random Forest Classifier (120 Estimators)</a:t>
             </a:r>
           </a:p>
         </p:txBody>
@@ -8232,7 +8232,7 @@
               </a:defRPr>
             </a:pPr>
             <a:r>
-              <a:t>✓ 16/16 APIs Verified</a:t>
+              <a:t>✓ 100% Strict Type Safety</a:t>
             </a:r>
           </a:p>
           <a:p>
@@ -8244,7 +8244,7 @@
               </a:defRPr>
             </a:pPr>
             <a:r>
-              <a:t>Health, Auth, Predict, AI, PDF/CSV 200 OK</a:t>
+              <a:t>tsc --noEmit &amp; zero Python compilation errors</a:t>
             </a:r>
           </a:p>
         </p:txBody>
@@ -8324,7 +8324,7 @@
               </a:defRPr>
             </a:pPr>
             <a:r>
-              <a:t>✓ &lt; 50ms ML Latency</a:t>
+              <a:t>✓ 16/16 Audit Passed</a:t>
             </a:r>
           </a:p>
           <a:p>
@@ -8336,7 +8336,7 @@
               </a:defRPr>
             </a:pPr>
             <a:r>
-              <a:t>High-throughput Placement Inference</a:t>
+              <a:t>IDOR 403 Forbidden &amp; Security Verification</a:t>
             </a:r>
           </a:p>
         </p:txBody>
@@ -8416,7 +8416,7 @@
               </a:defRPr>
             </a:pPr>
             <a:r>
-              <a:t>✓ 100% Secret Protection</a:t>
+              <a:t>✓ Bilingual AI Mentorship</a:t>
             </a:r>
           </a:p>
           <a:p>
@@ -8428,7 +8428,7 @@
               </a:defRPr>
             </a:pPr>
             <a:r>
-              <a:t>.env Safely Guarded &amp; Git Excluded</a:t>
+              <a:t>English, Telugu Script &amp; Roman Telugu</a:t>
             </a:r>
           </a:p>
         </p:txBody>
@@ -8508,7 +8508,7 @@
               </a:defRPr>
             </a:pPr>
             <a:r>
-              <a:t>✓ Production Bundled</a:t>
+              <a:t>✓ Production Deployed</a:t>
             </a:r>
           </a:p>
           <a:p>
@@ -8520,7 +8520,7 @@
               </a:defRPr>
             </a:pPr>
             <a:r>
-              <a:t>Vite Minified &amp; Optimized</a:t>
+              <a:t>Vercel Edge SPA &amp; Render Cloud API Service</a:t>
             </a:r>
           </a:p>
         </p:txBody>

</xml_diff>

<commit_message>
feat(branding): redesign logo, keynote deck, and video demo player in obsidian ruby and amethyst violet (zero green, zero yellow, zero blue)
</commit_message>
<xml_diff>
--- a/Pathfinder_Presentation_Dileep_Bommali.pptx
+++ b/Pathfinder_Presentation_Dileep_Bommali.pptx
@@ -4162,7 +4162,7 @@
             <a:avLst/>
           </a:prstGeom>
           <a:solidFill>
-            <a:srgbClr val="0B0F19"/>
+            <a:srgbClr val="09090E"/>
           </a:solidFill>
           <a:ln>
             <a:noFill/>
@@ -4205,11 +4205,11 @@
             <a:avLst/>
           </a:prstGeom>
           <a:solidFill>
-            <a:srgbClr val="131A2A"/>
+            <a:srgbClr val="121018"/>
           </a:solidFill>
           <a:ln w="19050">
             <a:solidFill>
-              <a:srgbClr val="25314E"/>
+              <a:srgbClr val="302032"/>
             </a:solidFill>
           </a:ln>
         </p:spPr>
@@ -4260,7 +4260,7 @@
             <a:pPr algn="ctr">
               <a:defRPr sz="4600" b="1">
                 <a:solidFill>
-                  <a:srgbClr val="00E5FF"/>
+                  <a:srgbClr val="FF2D55"/>
                 </a:solidFill>
               </a:defRPr>
             </a:pPr>
@@ -4284,7 +4284,7 @@
             <a:pPr algn="ctr">
               <a:defRPr sz="1400">
                 <a:solidFill>
-                  <a:srgbClr val="25314E"/>
+                  <a:srgbClr val="302032"/>
                 </a:solidFill>
               </a:defRPr>
             </a:pPr>
@@ -4308,7 +4308,7 @@
             <a:pPr algn="ctr">
               <a:defRPr sz="1400">
                 <a:solidFill>
-                  <a:srgbClr val="94A3B8"/>
+                  <a:srgbClr val="A1A1AA"/>
                 </a:solidFill>
               </a:defRPr>
             </a:pPr>
@@ -4320,7 +4320,7 @@
             <a:pPr algn="ctr">
               <a:defRPr sz="1300">
                 <a:solidFill>
-                  <a:srgbClr val="00E5FF"/>
+                  <a:srgbClr val="FF2D55"/>
                 </a:solidFill>
               </a:defRPr>
             </a:pPr>
@@ -4363,7 +4363,7 @@
             <a:avLst/>
           </a:prstGeom>
           <a:solidFill>
-            <a:srgbClr val="0B0F19"/>
+            <a:srgbClr val="09090E"/>
           </a:solidFill>
           <a:ln>
             <a:noFill/>
@@ -4416,7 +4416,7 @@
             <a:pPr>
               <a:defRPr sz="1100" b="1">
                 <a:solidFill>
-                  <a:srgbClr val="00E5FF"/>
+                  <a:srgbClr val="FF2D55"/>
                 </a:solidFill>
               </a:defRPr>
             </a:pPr>
@@ -4476,11 +4476,11 @@
             <a:avLst/>
           </a:prstGeom>
           <a:solidFill>
-            <a:srgbClr val="131A2A"/>
+            <a:srgbClr val="121018"/>
           </a:solidFill>
           <a:ln w="19050">
             <a:solidFill>
-              <a:srgbClr val="25314E"/>
+              <a:srgbClr val="302032"/>
             </a:solidFill>
           </a:ln>
         </p:spPr>
@@ -4531,7 +4531,7 @@
             <a:pPr>
               <a:defRPr sz="2000" b="1">
                 <a:solidFill>
-                  <a:srgbClr val="00E5FF"/>
+                  <a:srgbClr val="FF2D55"/>
                 </a:solidFill>
               </a:defRPr>
             </a:pPr>
@@ -4579,7 +4579,7 @@
             <a:pPr>
               <a:defRPr sz="1200">
                 <a:solidFill>
-                  <a:srgbClr val="25314E"/>
+                  <a:srgbClr val="302032"/>
                 </a:solidFill>
               </a:defRPr>
             </a:pPr>
@@ -4603,7 +4603,7 @@
             <a:pPr>
               <a:defRPr sz="1400">
                 <a:solidFill>
-                  <a:srgbClr val="00E5FF"/>
+                  <a:srgbClr val="FF2D55"/>
                 </a:solidFill>
               </a:defRPr>
             </a:pPr>
@@ -4646,7 +4646,7 @@
             <a:avLst/>
           </a:prstGeom>
           <a:solidFill>
-            <a:srgbClr val="0B0F19"/>
+            <a:srgbClr val="09090E"/>
           </a:solidFill>
           <a:ln>
             <a:noFill/>
@@ -4699,7 +4699,7 @@
             <a:pPr>
               <a:defRPr sz="1100" b="1">
                 <a:solidFill>
-                  <a:srgbClr val="00E5FF"/>
+                  <a:srgbClr val="FF2D55"/>
                 </a:solidFill>
               </a:defRPr>
             </a:pPr>
@@ -4759,11 +4759,11 @@
             <a:avLst/>
           </a:prstGeom>
           <a:solidFill>
-            <a:srgbClr val="131A2A"/>
+            <a:srgbClr val="121018"/>
           </a:solidFill>
           <a:ln w="15240">
             <a:solidFill>
-              <a:srgbClr val="25314E"/>
+              <a:srgbClr val="302032"/>
             </a:solidFill>
           </a:ln>
         </p:spPr>
@@ -4814,7 +4814,7 @@
             <a:pPr>
               <a:defRPr sz="1700" b="1">
                 <a:solidFill>
-                  <a:srgbClr val="00E5FF"/>
+                  <a:srgbClr val="FF2D55"/>
                 </a:solidFill>
               </a:defRPr>
             </a:pPr>
@@ -4826,7 +4826,7 @@
             <a:pPr>
               <a:defRPr sz="1400">
                 <a:solidFill>
-                  <a:srgbClr val="94A3B8"/>
+                  <a:srgbClr val="A1A1AA"/>
                 </a:solidFill>
               </a:defRPr>
             </a:pPr>
@@ -4851,11 +4851,11 @@
             <a:avLst/>
           </a:prstGeom>
           <a:solidFill>
-            <a:srgbClr val="131A2A"/>
+            <a:srgbClr val="121018"/>
           </a:solidFill>
           <a:ln w="15240">
             <a:solidFill>
-              <a:srgbClr val="25314E"/>
+              <a:srgbClr val="302032"/>
             </a:solidFill>
           </a:ln>
         </p:spPr>
@@ -4906,7 +4906,7 @@
             <a:pPr>
               <a:defRPr sz="1700" b="1">
                 <a:solidFill>
-                  <a:srgbClr val="00E5FF"/>
+                  <a:srgbClr val="FF2D55"/>
                 </a:solidFill>
               </a:defRPr>
             </a:pPr>
@@ -4918,7 +4918,7 @@
             <a:pPr>
               <a:defRPr sz="1400">
                 <a:solidFill>
-                  <a:srgbClr val="94A3B8"/>
+                  <a:srgbClr val="A1A1AA"/>
                 </a:solidFill>
               </a:defRPr>
             </a:pPr>
@@ -4943,11 +4943,11 @@
             <a:avLst/>
           </a:prstGeom>
           <a:solidFill>
-            <a:srgbClr val="131A2A"/>
+            <a:srgbClr val="121018"/>
           </a:solidFill>
           <a:ln w="15240">
             <a:solidFill>
-              <a:srgbClr val="25314E"/>
+              <a:srgbClr val="302032"/>
             </a:solidFill>
           </a:ln>
         </p:spPr>
@@ -4998,7 +4998,7 @@
             <a:pPr>
               <a:defRPr sz="1700" b="1">
                 <a:solidFill>
-                  <a:srgbClr val="00E5FF"/>
+                  <a:srgbClr val="FF2D55"/>
                 </a:solidFill>
               </a:defRPr>
             </a:pPr>
@@ -5010,7 +5010,7 @@
             <a:pPr>
               <a:defRPr sz="1400">
                 <a:solidFill>
-                  <a:srgbClr val="94A3B8"/>
+                  <a:srgbClr val="A1A1AA"/>
                 </a:solidFill>
               </a:defRPr>
             </a:pPr>
@@ -5035,11 +5035,11 @@
             <a:avLst/>
           </a:prstGeom>
           <a:solidFill>
-            <a:srgbClr val="131A2A"/>
+            <a:srgbClr val="121018"/>
           </a:solidFill>
           <a:ln w="15240">
             <a:solidFill>
-              <a:srgbClr val="25314E"/>
+              <a:srgbClr val="302032"/>
             </a:solidFill>
           </a:ln>
         </p:spPr>
@@ -5090,7 +5090,7 @@
             <a:pPr>
               <a:defRPr sz="1700" b="1">
                 <a:solidFill>
-                  <a:srgbClr val="00E5FF"/>
+                  <a:srgbClr val="FF2D55"/>
                 </a:solidFill>
               </a:defRPr>
             </a:pPr>
@@ -5102,7 +5102,7 @@
             <a:pPr>
               <a:defRPr sz="1400">
                 <a:solidFill>
-                  <a:srgbClr val="94A3B8"/>
+                  <a:srgbClr val="A1A1AA"/>
                 </a:solidFill>
               </a:defRPr>
             </a:pPr>
@@ -5145,7 +5145,7 @@
             <a:avLst/>
           </a:prstGeom>
           <a:solidFill>
-            <a:srgbClr val="0B0F19"/>
+            <a:srgbClr val="09090E"/>
           </a:solidFill>
           <a:ln>
             <a:noFill/>
@@ -5198,7 +5198,7 @@
             <a:pPr>
               <a:defRPr sz="1100" b="1">
                 <a:solidFill>
-                  <a:srgbClr val="00E5FF"/>
+                  <a:srgbClr val="FF2D55"/>
                 </a:solidFill>
               </a:defRPr>
             </a:pPr>
@@ -5258,11 +5258,11 @@
             <a:avLst/>
           </a:prstGeom>
           <a:solidFill>
-            <a:srgbClr val="131A2A"/>
+            <a:srgbClr val="121018"/>
           </a:solidFill>
           <a:ln w="15240">
             <a:solidFill>
-              <a:srgbClr val="25314E"/>
+              <a:srgbClr val="302032"/>
             </a:solidFill>
           </a:ln>
         </p:spPr>
@@ -5325,7 +5325,7 @@
             <a:pPr>
               <a:defRPr sz="1800" b="1">
                 <a:solidFill>
-                  <a:srgbClr val="00E5FF"/>
+                  <a:srgbClr val="FF2D55"/>
                 </a:solidFill>
               </a:defRPr>
             </a:pPr>
@@ -5362,11 +5362,11 @@
             <a:avLst/>
           </a:prstGeom>
           <a:solidFill>
-            <a:srgbClr val="131A2A"/>
+            <a:srgbClr val="121018"/>
           </a:solidFill>
           <a:ln w="15240">
             <a:solidFill>
-              <a:srgbClr val="25314E"/>
+              <a:srgbClr val="302032"/>
             </a:solidFill>
           </a:ln>
         </p:spPr>
@@ -5429,7 +5429,7 @@
             <a:pPr>
               <a:defRPr sz="1800" b="1">
                 <a:solidFill>
-                  <a:srgbClr val="00E5FF"/>
+                  <a:srgbClr val="FF2D55"/>
                 </a:solidFill>
               </a:defRPr>
             </a:pPr>
@@ -5466,11 +5466,11 @@
             <a:avLst/>
           </a:prstGeom>
           <a:solidFill>
-            <a:srgbClr val="131A2A"/>
+            <a:srgbClr val="121018"/>
           </a:solidFill>
           <a:ln w="15240">
             <a:solidFill>
-              <a:srgbClr val="25314E"/>
+              <a:srgbClr val="302032"/>
             </a:solidFill>
           </a:ln>
         </p:spPr>
@@ -5533,7 +5533,7 @@
             <a:pPr>
               <a:defRPr sz="1800" b="1">
                 <a:solidFill>
-                  <a:srgbClr val="00E5FF"/>
+                  <a:srgbClr val="FF2D55"/>
                 </a:solidFill>
               </a:defRPr>
             </a:pPr>
@@ -5570,11 +5570,11 @@
             <a:avLst/>
           </a:prstGeom>
           <a:solidFill>
-            <a:srgbClr val="131A2A"/>
+            <a:srgbClr val="121018"/>
           </a:solidFill>
           <a:ln w="15240">
             <a:solidFill>
-              <a:srgbClr val="25314E"/>
+              <a:srgbClr val="302032"/>
             </a:solidFill>
           </a:ln>
         </p:spPr>
@@ -5637,7 +5637,7 @@
             <a:pPr>
               <a:defRPr sz="1800" b="1">
                 <a:solidFill>
-                  <a:srgbClr val="00E5FF"/>
+                  <a:srgbClr val="FF2D55"/>
                 </a:solidFill>
               </a:defRPr>
             </a:pPr>
@@ -5692,7 +5692,7 @@
             <a:avLst/>
           </a:prstGeom>
           <a:solidFill>
-            <a:srgbClr val="0B0F19"/>
+            <a:srgbClr val="09090E"/>
           </a:solidFill>
           <a:ln>
             <a:noFill/>
@@ -5745,7 +5745,7 @@
             <a:pPr>
               <a:defRPr sz="1100" b="1">
                 <a:solidFill>
-                  <a:srgbClr val="00E5FF"/>
+                  <a:srgbClr val="FF2D55"/>
                 </a:solidFill>
               </a:defRPr>
             </a:pPr>
@@ -5805,11 +5805,11 @@
             <a:avLst/>
           </a:prstGeom>
           <a:solidFill>
-            <a:srgbClr val="131A2A"/>
+            <a:srgbClr val="121018"/>
           </a:solidFill>
           <a:ln w="15240">
             <a:solidFill>
-              <a:srgbClr val="25314E"/>
+              <a:srgbClr val="302032"/>
             </a:solidFill>
           </a:ln>
         </p:spPr>
@@ -5872,7 +5872,7 @@
             <a:pPr>
               <a:defRPr sz="1800" b="1">
                 <a:solidFill>
-                  <a:srgbClr val="00E5FF"/>
+                  <a:srgbClr val="FF2D55"/>
                 </a:solidFill>
               </a:defRPr>
             </a:pPr>
@@ -5909,11 +5909,11 @@
             <a:avLst/>
           </a:prstGeom>
           <a:solidFill>
-            <a:srgbClr val="131A2A"/>
+            <a:srgbClr val="121018"/>
           </a:solidFill>
           <a:ln w="15240">
             <a:solidFill>
-              <a:srgbClr val="25314E"/>
+              <a:srgbClr val="302032"/>
             </a:solidFill>
           </a:ln>
         </p:spPr>
@@ -5976,7 +5976,7 @@
             <a:pPr>
               <a:defRPr sz="1800" b="1">
                 <a:solidFill>
-                  <a:srgbClr val="00E5FF"/>
+                  <a:srgbClr val="FF2D55"/>
                 </a:solidFill>
               </a:defRPr>
             </a:pPr>
@@ -6013,11 +6013,11 @@
             <a:avLst/>
           </a:prstGeom>
           <a:solidFill>
-            <a:srgbClr val="131A2A"/>
+            <a:srgbClr val="121018"/>
           </a:solidFill>
           <a:ln w="15240">
             <a:solidFill>
-              <a:srgbClr val="25314E"/>
+              <a:srgbClr val="302032"/>
             </a:solidFill>
           </a:ln>
         </p:spPr>
@@ -6080,7 +6080,7 @@
             <a:pPr>
               <a:defRPr sz="1800" b="1">
                 <a:solidFill>
-                  <a:srgbClr val="00E5FF"/>
+                  <a:srgbClr val="FF2D55"/>
                 </a:solidFill>
               </a:defRPr>
             </a:pPr>
@@ -6135,7 +6135,7 @@
             <a:avLst/>
           </a:prstGeom>
           <a:solidFill>
-            <a:srgbClr val="0B0F19"/>
+            <a:srgbClr val="09090E"/>
           </a:solidFill>
           <a:ln>
             <a:noFill/>
@@ -6188,7 +6188,7 @@
             <a:pPr>
               <a:defRPr sz="1100" b="1">
                 <a:solidFill>
-                  <a:srgbClr val="00E5FF"/>
+                  <a:srgbClr val="FF2D55"/>
                 </a:solidFill>
               </a:defRPr>
             </a:pPr>
@@ -6248,11 +6248,11 @@
             <a:avLst/>
           </a:prstGeom>
           <a:solidFill>
-            <a:srgbClr val="131A2A"/>
+            <a:srgbClr val="121018"/>
           </a:solidFill>
           <a:ln>
             <a:solidFill>
-              <a:srgbClr val="25314E"/>
+              <a:srgbClr val="302032"/>
             </a:solidFill>
           </a:ln>
         </p:spPr>
@@ -6303,7 +6303,7 @@
             <a:pPr>
               <a:defRPr sz="1900" b="1">
                 <a:solidFill>
-                  <a:srgbClr val="00E5FF"/>
+                  <a:srgbClr val="FF2D55"/>
                 </a:solidFill>
               </a:defRPr>
             </a:pPr>
@@ -6388,11 +6388,11 @@
             <a:avLst/>
           </a:prstGeom>
           <a:solidFill>
-            <a:srgbClr val="131A2A"/>
+            <a:srgbClr val="121018"/>
           </a:solidFill>
           <a:ln>
             <a:solidFill>
-              <a:srgbClr val="25314E"/>
+              <a:srgbClr val="302032"/>
             </a:solidFill>
           </a:ln>
         </p:spPr>
@@ -6546,7 +6546,7 @@
             <a:avLst/>
           </a:prstGeom>
           <a:solidFill>
-            <a:srgbClr val="0B0F19"/>
+            <a:srgbClr val="09090E"/>
           </a:solidFill>
           <a:ln>
             <a:noFill/>
@@ -6599,7 +6599,7 @@
             <a:pPr>
               <a:defRPr sz="1100" b="1">
                 <a:solidFill>
-                  <a:srgbClr val="00E5FF"/>
+                  <a:srgbClr val="FF2D55"/>
                 </a:solidFill>
               </a:defRPr>
             </a:pPr>
@@ -6659,11 +6659,11 @@
             <a:avLst/>
           </a:prstGeom>
           <a:solidFill>
-            <a:srgbClr val="131A2A"/>
+            <a:srgbClr val="121018"/>
           </a:solidFill>
           <a:ln>
             <a:solidFill>
-              <a:srgbClr val="25314E"/>
+              <a:srgbClr val="302032"/>
             </a:solidFill>
           </a:ln>
         </p:spPr>
@@ -6714,7 +6714,7 @@
             <a:pPr>
               <a:defRPr sz="1200" b="1">
                 <a:solidFill>
-                  <a:srgbClr val="00E5FF"/>
+                  <a:srgbClr val="FF2D55"/>
                 </a:solidFill>
               </a:defRPr>
             </a:pPr>
@@ -6738,7 +6738,7 @@
             <a:pPr>
               <a:defRPr sz="1400">
                 <a:solidFill>
-                  <a:srgbClr val="94A3B8"/>
+                  <a:srgbClr val="A1A1AA"/>
                 </a:solidFill>
               </a:defRPr>
             </a:pPr>
@@ -6763,11 +6763,11 @@
             <a:avLst/>
           </a:prstGeom>
           <a:solidFill>
-            <a:srgbClr val="131A2A"/>
+            <a:srgbClr val="121018"/>
           </a:solidFill>
           <a:ln>
             <a:solidFill>
-              <a:srgbClr val="25314E"/>
+              <a:srgbClr val="302032"/>
             </a:solidFill>
           </a:ln>
         </p:spPr>
@@ -6818,7 +6818,7 @@
             <a:pPr>
               <a:defRPr sz="1200" b="1">
                 <a:solidFill>
-                  <a:srgbClr val="00E5FF"/>
+                  <a:srgbClr val="FF2D55"/>
                 </a:solidFill>
               </a:defRPr>
             </a:pPr>
@@ -6842,7 +6842,7 @@
             <a:pPr>
               <a:defRPr sz="1400">
                 <a:solidFill>
-                  <a:srgbClr val="94A3B8"/>
+                  <a:srgbClr val="A1A1AA"/>
                 </a:solidFill>
               </a:defRPr>
             </a:pPr>
@@ -6867,11 +6867,11 @@
             <a:avLst/>
           </a:prstGeom>
           <a:solidFill>
-            <a:srgbClr val="131A2A"/>
+            <a:srgbClr val="121018"/>
           </a:solidFill>
           <a:ln>
             <a:solidFill>
-              <a:srgbClr val="25314E"/>
+              <a:srgbClr val="302032"/>
             </a:solidFill>
           </a:ln>
         </p:spPr>
@@ -6922,7 +6922,7 @@
             <a:pPr>
               <a:defRPr sz="1200" b="1">
                 <a:solidFill>
-                  <a:srgbClr val="00E5FF"/>
+                  <a:srgbClr val="FF2D55"/>
                 </a:solidFill>
               </a:defRPr>
             </a:pPr>
@@ -6946,7 +6946,7 @@
             <a:pPr>
               <a:defRPr sz="1400">
                 <a:solidFill>
-                  <a:srgbClr val="94A3B8"/>
+                  <a:srgbClr val="A1A1AA"/>
                 </a:solidFill>
               </a:defRPr>
             </a:pPr>
@@ -6989,7 +6989,7 @@
             <a:avLst/>
           </a:prstGeom>
           <a:solidFill>
-            <a:srgbClr val="0B0F19"/>
+            <a:srgbClr val="09090E"/>
           </a:solidFill>
           <a:ln>
             <a:noFill/>
@@ -7042,7 +7042,7 @@
             <a:pPr>
               <a:defRPr sz="1100" b="1">
                 <a:solidFill>
-                  <a:srgbClr val="00E5FF"/>
+                  <a:srgbClr val="FF2D55"/>
                 </a:solidFill>
               </a:defRPr>
             </a:pPr>
@@ -7102,11 +7102,11 @@
             <a:avLst/>
           </a:prstGeom>
           <a:solidFill>
-            <a:srgbClr val="131A2A"/>
+            <a:srgbClr val="121018"/>
           </a:solidFill>
           <a:ln>
             <a:solidFill>
-              <a:srgbClr val="25314E"/>
+              <a:srgbClr val="302032"/>
             </a:solidFill>
           </a:ln>
         </p:spPr>
@@ -7169,7 +7169,7 @@
             <a:pPr>
               <a:defRPr sz="1900" b="1">
                 <a:solidFill>
-                  <a:srgbClr val="00E5FF"/>
+                  <a:srgbClr val="FF2D55"/>
                 </a:solidFill>
               </a:defRPr>
             </a:pPr>
@@ -7206,11 +7206,11 @@
             <a:avLst/>
           </a:prstGeom>
           <a:solidFill>
-            <a:srgbClr val="131A2A"/>
+            <a:srgbClr val="121018"/>
           </a:solidFill>
           <a:ln>
             <a:solidFill>
-              <a:srgbClr val="25314E"/>
+              <a:srgbClr val="302032"/>
             </a:solidFill>
           </a:ln>
         </p:spPr>
@@ -7273,7 +7273,7 @@
             <a:pPr>
               <a:defRPr sz="1900" b="1">
                 <a:solidFill>
-                  <a:srgbClr val="00E5FF"/>
+                  <a:srgbClr val="FF2D55"/>
                 </a:solidFill>
               </a:defRPr>
             </a:pPr>
@@ -7310,11 +7310,11 @@
             <a:avLst/>
           </a:prstGeom>
           <a:solidFill>
-            <a:srgbClr val="131A2A"/>
+            <a:srgbClr val="121018"/>
           </a:solidFill>
           <a:ln>
             <a:solidFill>
-              <a:srgbClr val="25314E"/>
+              <a:srgbClr val="302032"/>
             </a:solidFill>
           </a:ln>
         </p:spPr>
@@ -7377,7 +7377,7 @@
             <a:pPr>
               <a:defRPr sz="1900" b="1">
                 <a:solidFill>
-                  <a:srgbClr val="00E5FF"/>
+                  <a:srgbClr val="FF2D55"/>
                 </a:solidFill>
               </a:defRPr>
             </a:pPr>
@@ -7432,7 +7432,7 @@
             <a:avLst/>
           </a:prstGeom>
           <a:solidFill>
-            <a:srgbClr val="0B0F19"/>
+            <a:srgbClr val="09090E"/>
           </a:solidFill>
           <a:ln>
             <a:noFill/>
@@ -7485,7 +7485,7 @@
             <a:pPr>
               <a:defRPr sz="1100" b="1">
                 <a:solidFill>
-                  <a:srgbClr val="00E5FF"/>
+                  <a:srgbClr val="FF2D55"/>
                 </a:solidFill>
               </a:defRPr>
             </a:pPr>
@@ -7545,11 +7545,11 @@
             <a:avLst/>
           </a:prstGeom>
           <a:solidFill>
-            <a:srgbClr val="131A2A"/>
+            <a:srgbClr val="121018"/>
           </a:solidFill>
           <a:ln>
             <a:solidFill>
-              <a:srgbClr val="25314E"/>
+              <a:srgbClr val="302032"/>
             </a:solidFill>
           </a:ln>
         </p:spPr>
@@ -7600,7 +7600,7 @@
             <a:pPr>
               <a:defRPr sz="1200" b="1">
                 <a:solidFill>
-                  <a:srgbClr val="00E5FF"/>
+                  <a:srgbClr val="FF2D55"/>
                 </a:solidFill>
               </a:defRPr>
             </a:pPr>
@@ -7624,7 +7624,7 @@
             <a:pPr>
               <a:defRPr sz="1400">
                 <a:solidFill>
-                  <a:srgbClr val="94A3B8"/>
+                  <a:srgbClr val="A1A1AA"/>
                 </a:solidFill>
               </a:defRPr>
             </a:pPr>
@@ -7649,11 +7649,11 @@
             <a:avLst/>
           </a:prstGeom>
           <a:solidFill>
-            <a:srgbClr val="131A2A"/>
+            <a:srgbClr val="121018"/>
           </a:solidFill>
           <a:ln>
             <a:solidFill>
-              <a:srgbClr val="25314E"/>
+              <a:srgbClr val="302032"/>
             </a:solidFill>
           </a:ln>
         </p:spPr>
@@ -7704,7 +7704,7 @@
             <a:pPr>
               <a:defRPr sz="1200" b="1">
                 <a:solidFill>
-                  <a:srgbClr val="00E5FF"/>
+                  <a:srgbClr val="FF2D55"/>
                 </a:solidFill>
               </a:defRPr>
             </a:pPr>
@@ -7728,7 +7728,7 @@
             <a:pPr>
               <a:defRPr sz="1400">
                 <a:solidFill>
-                  <a:srgbClr val="94A3B8"/>
+                  <a:srgbClr val="A1A1AA"/>
                 </a:solidFill>
               </a:defRPr>
             </a:pPr>
@@ -7753,11 +7753,11 @@
             <a:avLst/>
           </a:prstGeom>
           <a:solidFill>
-            <a:srgbClr val="131A2A"/>
+            <a:srgbClr val="121018"/>
           </a:solidFill>
           <a:ln>
             <a:solidFill>
-              <a:srgbClr val="25314E"/>
+              <a:srgbClr val="302032"/>
             </a:solidFill>
           </a:ln>
         </p:spPr>
@@ -7808,7 +7808,7 @@
             <a:pPr>
               <a:defRPr sz="1200" b="1">
                 <a:solidFill>
-                  <a:srgbClr val="00E5FF"/>
+                  <a:srgbClr val="FF2D55"/>
                 </a:solidFill>
               </a:defRPr>
             </a:pPr>
@@ -7832,7 +7832,7 @@
             <a:pPr>
               <a:defRPr sz="1400">
                 <a:solidFill>
-                  <a:srgbClr val="94A3B8"/>
+                  <a:srgbClr val="A1A1AA"/>
                 </a:solidFill>
               </a:defRPr>
             </a:pPr>
@@ -7875,7 +7875,7 @@
             <a:avLst/>
           </a:prstGeom>
           <a:solidFill>
-            <a:srgbClr val="0B0F19"/>
+            <a:srgbClr val="09090E"/>
           </a:solidFill>
           <a:ln>
             <a:noFill/>
@@ -7928,7 +7928,7 @@
             <a:pPr>
               <a:defRPr sz="1100" b="1">
                 <a:solidFill>
-                  <a:srgbClr val="00E5FF"/>
+                  <a:srgbClr val="FF2D55"/>
                 </a:solidFill>
               </a:defRPr>
             </a:pPr>
@@ -7988,11 +7988,11 @@
             <a:avLst/>
           </a:prstGeom>
           <a:solidFill>
-            <a:srgbClr val="131A2A"/>
+            <a:srgbClr val="121018"/>
           </a:solidFill>
           <a:ln>
             <a:solidFill>
-              <a:srgbClr val="25314E"/>
+              <a:srgbClr val="302032"/>
             </a:solidFill>
           </a:ln>
         </p:spPr>
@@ -8043,7 +8043,7 @@
             <a:pPr>
               <a:defRPr sz="1800" b="1">
                 <a:solidFill>
-                  <a:srgbClr val="00E5FF"/>
+                  <a:srgbClr val="FF2D55"/>
                 </a:solidFill>
               </a:defRPr>
             </a:pPr>
@@ -8055,7 +8055,7 @@
             <a:pPr>
               <a:defRPr sz="1300">
                 <a:solidFill>
-                  <a:srgbClr val="94A3B8"/>
+                  <a:srgbClr val="A1A1AA"/>
                 </a:solidFill>
               </a:defRPr>
             </a:pPr>
@@ -8080,11 +8080,11 @@
             <a:avLst/>
           </a:prstGeom>
           <a:solidFill>
-            <a:srgbClr val="131A2A"/>
+            <a:srgbClr val="121018"/>
           </a:solidFill>
           <a:ln>
             <a:solidFill>
-              <a:srgbClr val="25314E"/>
+              <a:srgbClr val="302032"/>
             </a:solidFill>
           </a:ln>
         </p:spPr>
@@ -8135,7 +8135,7 @@
             <a:pPr>
               <a:defRPr sz="1800" b="1">
                 <a:solidFill>
-                  <a:srgbClr val="00E5FF"/>
+                  <a:srgbClr val="FF2D55"/>
                 </a:solidFill>
               </a:defRPr>
             </a:pPr>
@@ -8147,7 +8147,7 @@
             <a:pPr>
               <a:defRPr sz="1300">
                 <a:solidFill>
-                  <a:srgbClr val="94A3B8"/>
+                  <a:srgbClr val="A1A1AA"/>
                 </a:solidFill>
               </a:defRPr>
             </a:pPr>
@@ -8172,11 +8172,11 @@
             <a:avLst/>
           </a:prstGeom>
           <a:solidFill>
-            <a:srgbClr val="131A2A"/>
+            <a:srgbClr val="121018"/>
           </a:solidFill>
           <a:ln>
             <a:solidFill>
-              <a:srgbClr val="25314E"/>
+              <a:srgbClr val="302032"/>
             </a:solidFill>
           </a:ln>
         </p:spPr>
@@ -8227,7 +8227,7 @@
             <a:pPr>
               <a:defRPr sz="1800" b="1">
                 <a:solidFill>
-                  <a:srgbClr val="00E5FF"/>
+                  <a:srgbClr val="FF2D55"/>
                 </a:solidFill>
               </a:defRPr>
             </a:pPr>
@@ -8239,7 +8239,7 @@
             <a:pPr>
               <a:defRPr sz="1300">
                 <a:solidFill>
-                  <a:srgbClr val="94A3B8"/>
+                  <a:srgbClr val="A1A1AA"/>
                 </a:solidFill>
               </a:defRPr>
             </a:pPr>
@@ -8264,11 +8264,11 @@
             <a:avLst/>
           </a:prstGeom>
           <a:solidFill>
-            <a:srgbClr val="131A2A"/>
+            <a:srgbClr val="121018"/>
           </a:solidFill>
           <a:ln>
             <a:solidFill>
-              <a:srgbClr val="25314E"/>
+              <a:srgbClr val="302032"/>
             </a:solidFill>
           </a:ln>
         </p:spPr>
@@ -8319,7 +8319,7 @@
             <a:pPr>
               <a:defRPr sz="1800" b="1">
                 <a:solidFill>
-                  <a:srgbClr val="00E5FF"/>
+                  <a:srgbClr val="FF2D55"/>
                 </a:solidFill>
               </a:defRPr>
             </a:pPr>
@@ -8331,7 +8331,7 @@
             <a:pPr>
               <a:defRPr sz="1300">
                 <a:solidFill>
-                  <a:srgbClr val="94A3B8"/>
+                  <a:srgbClr val="A1A1AA"/>
                 </a:solidFill>
               </a:defRPr>
             </a:pPr>
@@ -8356,11 +8356,11 @@
             <a:avLst/>
           </a:prstGeom>
           <a:solidFill>
-            <a:srgbClr val="131A2A"/>
+            <a:srgbClr val="121018"/>
           </a:solidFill>
           <a:ln>
             <a:solidFill>
-              <a:srgbClr val="25314E"/>
+              <a:srgbClr val="302032"/>
             </a:solidFill>
           </a:ln>
         </p:spPr>
@@ -8411,7 +8411,7 @@
             <a:pPr>
               <a:defRPr sz="1800" b="1">
                 <a:solidFill>
-                  <a:srgbClr val="00E5FF"/>
+                  <a:srgbClr val="FF2D55"/>
                 </a:solidFill>
               </a:defRPr>
             </a:pPr>
@@ -8423,7 +8423,7 @@
             <a:pPr>
               <a:defRPr sz="1300">
                 <a:solidFill>
-                  <a:srgbClr val="94A3B8"/>
+                  <a:srgbClr val="A1A1AA"/>
                 </a:solidFill>
               </a:defRPr>
             </a:pPr>
@@ -8448,11 +8448,11 @@
             <a:avLst/>
           </a:prstGeom>
           <a:solidFill>
-            <a:srgbClr val="131A2A"/>
+            <a:srgbClr val="121018"/>
           </a:solidFill>
           <a:ln>
             <a:solidFill>
-              <a:srgbClr val="25314E"/>
+              <a:srgbClr val="302032"/>
             </a:solidFill>
           </a:ln>
         </p:spPr>
@@ -8503,7 +8503,7 @@
             <a:pPr>
               <a:defRPr sz="1800" b="1">
                 <a:solidFill>
-                  <a:srgbClr val="00E5FF"/>
+                  <a:srgbClr val="FF2D55"/>
                 </a:solidFill>
               </a:defRPr>
             </a:pPr>
@@ -8515,7 +8515,7 @@
             <a:pPr>
               <a:defRPr sz="1300">
                 <a:solidFill>
-                  <a:srgbClr val="94A3B8"/>
+                  <a:srgbClr val="A1A1AA"/>
                 </a:solidFill>
               </a:defRPr>
             </a:pPr>

</xml_diff>